<commit_message>
docs: remove concluding note from presentation
</commit_message>
<xml_diff>
--- a/presentation/Gemini-Study-Assistant.pptx
+++ b/presentation/Gemini-Study-Assistant.pptx
@@ -2,18 +2,18 @@
 <file path=ppt/presentation.xml><?xml version="1.0" encoding="utf-8"?>
 <p:presentation xmlns:p="http://schemas.openxmlformats.org/presentationml/2006/main">
   <p:sldMasterIdLst>
-    <p:sldMasterId xmlns:r="http://schemas.openxmlformats.org/officeDocument/2006/relationships" id="2147483648" r:id="R23e1cb323fea462a"/>
+    <p:sldMasterId xmlns:r="http://schemas.openxmlformats.org/officeDocument/2006/relationships" id="2147483648" r:id="R3498bd3b7ebe4c37"/>
   </p:sldMasterIdLst>
   <p:notesMasterIdLst>
-    <p:notesMasterId xmlns:r="http://schemas.openxmlformats.org/officeDocument/2006/relationships" r:id="R89b10bae46e24f12"/>
+    <p:notesMasterId xmlns:r="http://schemas.openxmlformats.org/officeDocument/2006/relationships" r:id="R8cde2620b2fb42cc"/>
   </p:notesMasterIdLst>
   <p:sldIdLst>
-    <p:sldId xmlns:r="http://schemas.openxmlformats.org/officeDocument/2006/relationships" id="256" r:id="R4282983e3b7c41d9"/>
-    <p:sldId xmlns:r="http://schemas.openxmlformats.org/officeDocument/2006/relationships" id="257" r:id="R683080161e1a480f"/>
-    <p:sldId xmlns:r="http://schemas.openxmlformats.org/officeDocument/2006/relationships" id="258" r:id="Rd31d6318867e445e"/>
-    <p:sldId xmlns:r="http://schemas.openxmlformats.org/officeDocument/2006/relationships" id="259" r:id="R94ecba83131e4f39"/>
-    <p:sldId xmlns:r="http://schemas.openxmlformats.org/officeDocument/2006/relationships" id="260" r:id="Ra1f56d4b73824beb"/>
-    <p:sldId xmlns:r="http://schemas.openxmlformats.org/officeDocument/2006/relationships" id="261" r:id="R5ec9d718acfc4334"/>
+    <p:sldId xmlns:r="http://schemas.openxmlformats.org/officeDocument/2006/relationships" id="256" r:id="R0e5a6801836d4955"/>
+    <p:sldId xmlns:r="http://schemas.openxmlformats.org/officeDocument/2006/relationships" id="257" r:id="Rad4b57ce162e4a9a"/>
+    <p:sldId xmlns:r="http://schemas.openxmlformats.org/officeDocument/2006/relationships" id="258" r:id="Rdaa2741231d2477b"/>
+    <p:sldId xmlns:r="http://schemas.openxmlformats.org/officeDocument/2006/relationships" id="259" r:id="Rb3eb1322e490427e"/>
+    <p:sldId xmlns:r="http://schemas.openxmlformats.org/officeDocument/2006/relationships" id="260" r:id="Rae41ec5a44634d39"/>
+    <p:sldId xmlns:r="http://schemas.openxmlformats.org/officeDocument/2006/relationships" id="261" r:id="R23ad0a9434234b51"/>
   </p:sldIdLst>
   <p:sldSz cx="12192000" cy="6858000"/>
   <p:notesSz cx="6858000" cy="9144000"/>
@@ -895,6 +895,7 @@
                 <a:spcPts val="0"/>
               </a:spcAft>
               <a:buNone/>
+              <a:defRPr/>
             </a:lvl1pPr>
             <a:lvl2pPr marL="0" indent="0">
               <a:lnSpc>
@@ -907,6 +908,7 @@
                 <a:spcPts val="0"/>
               </a:spcAft>
               <a:buNone/>
+              <a:defRPr/>
             </a:lvl2pPr>
             <a:lvl3pPr marL="0" indent="0">
               <a:lnSpc>
@@ -919,6 +921,7 @@
                 <a:spcPts val="0"/>
               </a:spcAft>
               <a:buNone/>
+              <a:defRPr/>
             </a:lvl3pPr>
             <a:lvl4pPr marL="0" indent="0">
               <a:lnSpc>
@@ -931,6 +934,7 @@
                 <a:spcPts val="0"/>
               </a:spcAft>
               <a:buNone/>
+              <a:defRPr/>
             </a:lvl4pPr>
             <a:lvl5pPr marL="0" indent="0">
               <a:lnSpc>
@@ -943,6 +947,7 @@
                 <a:spcPts val="0"/>
               </a:spcAft>
               <a:buNone/>
+              <a:defRPr/>
             </a:lvl5pPr>
             <a:lvl6pPr marL="0" indent="0">
               <a:lnSpc>
@@ -955,6 +960,7 @@
                 <a:spcPts val="0"/>
               </a:spcAft>
               <a:buNone/>
+              <a:defRPr/>
             </a:lvl6pPr>
             <a:lvl7pPr marL="0" indent="0">
               <a:lnSpc>
@@ -967,6 +973,7 @@
                 <a:spcPts val="0"/>
               </a:spcAft>
               <a:buNone/>
+              <a:defRPr/>
             </a:lvl7pPr>
             <a:lvl8pPr marL="0" indent="0">
               <a:lnSpc>
@@ -979,6 +986,7 @@
                 <a:spcPts val="0"/>
               </a:spcAft>
               <a:buNone/>
+              <a:defRPr/>
             </a:lvl8pPr>
             <a:lvl9pPr marL="0" indent="0">
               <a:lnSpc>
@@ -991,6 +999,7 @@
                 <a:spcPts val="0"/>
               </a:spcAft>
               <a:buNone/>
+              <a:defRPr/>
             </a:lvl9pPr>
           </a:lstStyle>
           <a:p xmlns:a="http://schemas.openxmlformats.org/drawingml/2006/main"/>
@@ -1052,6 +1061,7 @@
                 <a:spcPts val="0"/>
               </a:spcAft>
               <a:buNone/>
+              <a:defRPr/>
             </a:lvl1pPr>
             <a:lvl2pPr marL="0" indent="0">
               <a:lnSpc>
@@ -1064,6 +1074,7 @@
                 <a:spcPts val="0"/>
               </a:spcAft>
               <a:buNone/>
+              <a:defRPr/>
             </a:lvl2pPr>
             <a:lvl3pPr marL="0" indent="0">
               <a:lnSpc>
@@ -1076,6 +1087,7 @@
                 <a:spcPts val="0"/>
               </a:spcAft>
               <a:buNone/>
+              <a:defRPr/>
             </a:lvl3pPr>
             <a:lvl4pPr marL="0" indent="0">
               <a:lnSpc>
@@ -1088,6 +1100,7 @@
                 <a:spcPts val="0"/>
               </a:spcAft>
               <a:buNone/>
+              <a:defRPr/>
             </a:lvl4pPr>
             <a:lvl5pPr marL="0" indent="0">
               <a:lnSpc>
@@ -1100,6 +1113,7 @@
                 <a:spcPts val="0"/>
               </a:spcAft>
               <a:buNone/>
+              <a:defRPr/>
             </a:lvl5pPr>
             <a:lvl6pPr marL="0" indent="0">
               <a:lnSpc>
@@ -1112,6 +1126,7 @@
                 <a:spcPts val="0"/>
               </a:spcAft>
               <a:buNone/>
+              <a:defRPr/>
             </a:lvl6pPr>
             <a:lvl7pPr marL="0" indent="0">
               <a:lnSpc>
@@ -1124,6 +1139,7 @@
                 <a:spcPts val="0"/>
               </a:spcAft>
               <a:buNone/>
+              <a:defRPr/>
             </a:lvl7pPr>
             <a:lvl8pPr marL="0" indent="0">
               <a:lnSpc>
@@ -1136,6 +1152,7 @@
                 <a:spcPts val="0"/>
               </a:spcAft>
               <a:buNone/>
+              <a:defRPr/>
             </a:lvl8pPr>
             <a:lvl9pPr marL="0" indent="0">
               <a:lnSpc>
@@ -1148,6 +1165,7 @@
                 <a:spcPts val="0"/>
               </a:spcAft>
               <a:buNone/>
+              <a:defRPr/>
             </a:lvl9pPr>
           </a:lstStyle>
           <a:p xmlns:a="http://schemas.openxmlformats.org/drawingml/2006/main"/>
@@ -1226,6 +1244,7 @@
                 <a:spcPts val="0"/>
               </a:spcAft>
               <a:buNone/>
+              <a:defRPr/>
             </a:lvl1pPr>
             <a:lvl2pPr marL="0" indent="0">
               <a:lnSpc>
@@ -1238,6 +1257,7 @@
                 <a:spcPts val="0"/>
               </a:spcAft>
               <a:buNone/>
+              <a:defRPr/>
             </a:lvl2pPr>
             <a:lvl3pPr marL="0" indent="0">
               <a:lnSpc>
@@ -1250,6 +1270,7 @@
                 <a:spcPts val="0"/>
               </a:spcAft>
               <a:buNone/>
+              <a:defRPr/>
             </a:lvl3pPr>
             <a:lvl4pPr marL="0" indent="0">
               <a:lnSpc>
@@ -1262,6 +1283,7 @@
                 <a:spcPts val="0"/>
               </a:spcAft>
               <a:buNone/>
+              <a:defRPr/>
             </a:lvl4pPr>
             <a:lvl5pPr marL="0" indent="0">
               <a:lnSpc>
@@ -1274,6 +1296,7 @@
                 <a:spcPts val="0"/>
               </a:spcAft>
               <a:buNone/>
+              <a:defRPr/>
             </a:lvl5pPr>
             <a:lvl6pPr marL="0" indent="0">
               <a:lnSpc>
@@ -1286,6 +1309,7 @@
                 <a:spcPts val="0"/>
               </a:spcAft>
               <a:buNone/>
+              <a:defRPr/>
             </a:lvl6pPr>
             <a:lvl7pPr marL="0" indent="0">
               <a:lnSpc>
@@ -1298,6 +1322,7 @@
                 <a:spcPts val="0"/>
               </a:spcAft>
               <a:buNone/>
+              <a:defRPr/>
             </a:lvl7pPr>
             <a:lvl8pPr marL="0" indent="0">
               <a:lnSpc>
@@ -1310,6 +1335,7 @@
                 <a:spcPts val="0"/>
               </a:spcAft>
               <a:buNone/>
+              <a:defRPr/>
             </a:lvl8pPr>
             <a:lvl9pPr marL="0" indent="0">
               <a:lnSpc>
@@ -1322,6 +1348,7 @@
                 <a:spcPts val="0"/>
               </a:spcAft>
               <a:buNone/>
+              <a:defRPr/>
             </a:lvl9pPr>
           </a:lstStyle>
           <a:p xmlns:a="http://schemas.openxmlformats.org/drawingml/2006/main"/>
@@ -1400,6 +1427,7 @@
                 <a:spcPts val="0"/>
               </a:spcAft>
               <a:buNone/>
+              <a:defRPr/>
             </a:lvl1pPr>
             <a:lvl2pPr marL="0" indent="0">
               <a:lnSpc>
@@ -1412,6 +1440,7 @@
                 <a:spcPts val="0"/>
               </a:spcAft>
               <a:buNone/>
+              <a:defRPr/>
             </a:lvl2pPr>
             <a:lvl3pPr marL="0" indent="0">
               <a:lnSpc>
@@ -1424,6 +1453,7 @@
                 <a:spcPts val="0"/>
               </a:spcAft>
               <a:buNone/>
+              <a:defRPr/>
             </a:lvl3pPr>
             <a:lvl4pPr marL="0" indent="0">
               <a:lnSpc>
@@ -1436,6 +1466,7 @@
                 <a:spcPts val="0"/>
               </a:spcAft>
               <a:buNone/>
+              <a:defRPr/>
             </a:lvl4pPr>
             <a:lvl5pPr marL="0" indent="0">
               <a:lnSpc>
@@ -1448,6 +1479,7 @@
                 <a:spcPts val="0"/>
               </a:spcAft>
               <a:buNone/>
+              <a:defRPr/>
             </a:lvl5pPr>
             <a:lvl6pPr marL="0" indent="0">
               <a:lnSpc>
@@ -1460,6 +1492,7 @@
                 <a:spcPts val="0"/>
               </a:spcAft>
               <a:buNone/>
+              <a:defRPr/>
             </a:lvl6pPr>
             <a:lvl7pPr marL="0" indent="0">
               <a:lnSpc>
@@ -1472,6 +1505,7 @@
                 <a:spcPts val="0"/>
               </a:spcAft>
               <a:buNone/>
+              <a:defRPr/>
             </a:lvl7pPr>
             <a:lvl8pPr marL="0" indent="0">
               <a:lnSpc>
@@ -1484,6 +1518,7 @@
                 <a:spcPts val="0"/>
               </a:spcAft>
               <a:buNone/>
+              <a:defRPr/>
             </a:lvl8pPr>
             <a:lvl9pPr marL="0" indent="0">
               <a:lnSpc>
@@ -1496,6 +1531,7 @@
                 <a:spcPts val="0"/>
               </a:spcAft>
               <a:buNone/>
+              <a:defRPr/>
             </a:lvl9pPr>
           </a:lstStyle>
           <a:p xmlns:a="http://schemas.openxmlformats.org/drawingml/2006/main"/>
@@ -1557,6 +1593,7 @@
                 <a:spcPts val="1200"/>
               </a:spcAft>
               <a:buChar char="•"/>
+              <a:defRPr/>
             </a:lvl1pPr>
             <a:lvl2pPr marL="533400" indent="-228600">
               <a:lnSpc>
@@ -1569,6 +1606,7 @@
                 <a:spcPts val="1200"/>
               </a:spcAft>
               <a:buChar char="•"/>
+              <a:defRPr/>
             </a:lvl2pPr>
             <a:lvl3pPr marL="838200" indent="-228600">
               <a:lnSpc>
@@ -1581,6 +1619,7 @@
                 <a:spcPts val="1200"/>
               </a:spcAft>
               <a:buChar char="•"/>
+              <a:defRPr/>
             </a:lvl3pPr>
             <a:lvl4pPr marL="1143000" indent="-228600">
               <a:lnSpc>
@@ -1593,6 +1632,7 @@
                 <a:spcPts val="1200"/>
               </a:spcAft>
               <a:buChar char="•"/>
+              <a:defRPr/>
             </a:lvl4pPr>
             <a:lvl5pPr marL="1447800" indent="-228600">
               <a:lnSpc>
@@ -1605,6 +1645,7 @@
                 <a:spcPts val="1200"/>
               </a:spcAft>
               <a:buChar char="•"/>
+              <a:defRPr/>
             </a:lvl5pPr>
             <a:lvl6pPr marL="1752600" indent="-228600">
               <a:lnSpc>
@@ -1617,6 +1658,7 @@
                 <a:spcPts val="1200"/>
               </a:spcAft>
               <a:buChar char="•"/>
+              <a:defRPr/>
             </a:lvl6pPr>
             <a:lvl7pPr marL="2057400" indent="-228600">
               <a:lnSpc>
@@ -1629,6 +1671,7 @@
                 <a:spcPts val="1200"/>
               </a:spcAft>
               <a:buChar char="•"/>
+              <a:defRPr/>
             </a:lvl7pPr>
             <a:lvl8pPr marL="2362200" indent="-228600">
               <a:lnSpc>
@@ -1641,6 +1684,7 @@
                 <a:spcPts val="1200"/>
               </a:spcAft>
               <a:buChar char="•"/>
+              <a:defRPr/>
             </a:lvl8pPr>
             <a:lvl9pPr marL="2667000" indent="-228600">
               <a:lnSpc>
@@ -1653,6 +1697,7 @@
                 <a:spcPts val="1200"/>
               </a:spcAft>
               <a:buChar char="•"/>
+              <a:defRPr/>
             </a:lvl9pPr>
           </a:lstStyle>
           <a:p xmlns:a="http://schemas.openxmlformats.org/drawingml/2006/main"/>
@@ -1731,6 +1776,7 @@
                 <a:spcPts val="0"/>
               </a:spcAft>
               <a:buNone/>
+              <a:defRPr/>
             </a:lvl1pPr>
             <a:lvl2pPr marL="0" indent="0">
               <a:lnSpc>
@@ -1743,6 +1789,7 @@
                 <a:spcPts val="0"/>
               </a:spcAft>
               <a:buNone/>
+              <a:defRPr/>
             </a:lvl2pPr>
             <a:lvl3pPr marL="0" indent="0">
               <a:lnSpc>
@@ -1755,6 +1802,7 @@
                 <a:spcPts val="0"/>
               </a:spcAft>
               <a:buNone/>
+              <a:defRPr/>
             </a:lvl3pPr>
             <a:lvl4pPr marL="0" indent="0">
               <a:lnSpc>
@@ -1767,6 +1815,7 @@
                 <a:spcPts val="0"/>
               </a:spcAft>
               <a:buNone/>
+              <a:defRPr/>
             </a:lvl4pPr>
             <a:lvl5pPr marL="0" indent="0">
               <a:lnSpc>
@@ -1779,6 +1828,7 @@
                 <a:spcPts val="0"/>
               </a:spcAft>
               <a:buNone/>
+              <a:defRPr/>
             </a:lvl5pPr>
             <a:lvl6pPr marL="0" indent="0">
               <a:lnSpc>
@@ -1791,6 +1841,7 @@
                 <a:spcPts val="0"/>
               </a:spcAft>
               <a:buNone/>
+              <a:defRPr/>
             </a:lvl6pPr>
             <a:lvl7pPr marL="0" indent="0">
               <a:lnSpc>
@@ -1803,6 +1854,7 @@
                 <a:spcPts val="0"/>
               </a:spcAft>
               <a:buNone/>
+              <a:defRPr/>
             </a:lvl7pPr>
             <a:lvl8pPr marL="0" indent="0">
               <a:lnSpc>
@@ -1815,6 +1867,7 @@
                 <a:spcPts val="0"/>
               </a:spcAft>
               <a:buNone/>
+              <a:defRPr/>
             </a:lvl8pPr>
             <a:lvl9pPr marL="0" indent="0">
               <a:lnSpc>
@@ -1827,6 +1880,7 @@
                 <a:spcPts val="0"/>
               </a:spcAft>
               <a:buNone/>
+              <a:defRPr/>
             </a:lvl9pPr>
           </a:lstStyle>
           <a:p xmlns:a="http://schemas.openxmlformats.org/drawingml/2006/main"/>
@@ -1888,6 +1942,7 @@
                 <a:spcPts val="1200"/>
               </a:spcAft>
               <a:buChar char="•"/>
+              <a:defRPr/>
             </a:lvl1pPr>
             <a:lvl2pPr marL="533400" indent="-228600">
               <a:lnSpc>
@@ -1900,6 +1955,7 @@
                 <a:spcPts val="1200"/>
               </a:spcAft>
               <a:buChar char="•"/>
+              <a:defRPr/>
             </a:lvl2pPr>
             <a:lvl3pPr marL="838200" indent="-228600">
               <a:lnSpc>
@@ -1912,6 +1968,7 @@
                 <a:spcPts val="1200"/>
               </a:spcAft>
               <a:buChar char="•"/>
+              <a:defRPr/>
             </a:lvl3pPr>
             <a:lvl4pPr marL="1143000" indent="-228600">
               <a:lnSpc>
@@ -1924,6 +1981,7 @@
                 <a:spcPts val="1200"/>
               </a:spcAft>
               <a:buChar char="•"/>
+              <a:defRPr/>
             </a:lvl4pPr>
             <a:lvl5pPr marL="1447800" indent="-228600">
               <a:lnSpc>
@@ -1936,6 +1994,7 @@
                 <a:spcPts val="1200"/>
               </a:spcAft>
               <a:buChar char="•"/>
+              <a:defRPr/>
             </a:lvl5pPr>
             <a:lvl6pPr marL="1752600" indent="-228600">
               <a:lnSpc>
@@ -1948,6 +2007,7 @@
                 <a:spcPts val="1200"/>
               </a:spcAft>
               <a:buChar char="•"/>
+              <a:defRPr/>
             </a:lvl6pPr>
             <a:lvl7pPr marL="2057400" indent="-228600">
               <a:lnSpc>
@@ -1960,6 +2020,7 @@
                 <a:spcPts val="1200"/>
               </a:spcAft>
               <a:buChar char="•"/>
+              <a:defRPr/>
             </a:lvl7pPr>
             <a:lvl8pPr marL="2362200" indent="-228600">
               <a:lnSpc>
@@ -1972,6 +2033,7 @@
                 <a:spcPts val="1200"/>
               </a:spcAft>
               <a:buChar char="•"/>
+              <a:defRPr/>
             </a:lvl8pPr>
             <a:lvl9pPr marL="2667000" indent="-228600">
               <a:lnSpc>
@@ -1984,6 +2046,7 @@
                 <a:spcPts val="1200"/>
               </a:spcAft>
               <a:buChar char="•"/>
+              <a:defRPr/>
             </a:lvl9pPr>
           </a:lstStyle>
           <a:p xmlns:a="http://schemas.openxmlformats.org/drawingml/2006/main"/>
@@ -2045,6 +2108,7 @@
                 <a:spcPts val="1200"/>
               </a:spcAft>
               <a:buChar char="•"/>
+              <a:defRPr/>
             </a:lvl1pPr>
             <a:lvl2pPr marL="533400" indent="-228600">
               <a:lnSpc>
@@ -2057,6 +2121,7 @@
                 <a:spcPts val="1200"/>
               </a:spcAft>
               <a:buChar char="•"/>
+              <a:defRPr/>
             </a:lvl2pPr>
             <a:lvl3pPr marL="838200" indent="-228600">
               <a:lnSpc>
@@ -2069,6 +2134,7 @@
                 <a:spcPts val="1200"/>
               </a:spcAft>
               <a:buChar char="•"/>
+              <a:defRPr/>
             </a:lvl3pPr>
             <a:lvl4pPr marL="1143000" indent="-228600">
               <a:lnSpc>
@@ -2081,6 +2147,7 @@
                 <a:spcPts val="1200"/>
               </a:spcAft>
               <a:buChar char="•"/>
+              <a:defRPr/>
             </a:lvl4pPr>
             <a:lvl5pPr marL="1447800" indent="-228600">
               <a:lnSpc>
@@ -2093,6 +2160,7 @@
                 <a:spcPts val="1200"/>
               </a:spcAft>
               <a:buChar char="•"/>
+              <a:defRPr/>
             </a:lvl5pPr>
             <a:lvl6pPr marL="1752600" indent="-228600">
               <a:lnSpc>
@@ -2105,6 +2173,7 @@
                 <a:spcPts val="1200"/>
               </a:spcAft>
               <a:buChar char="•"/>
+              <a:defRPr/>
             </a:lvl6pPr>
             <a:lvl7pPr marL="2057400" indent="-228600">
               <a:lnSpc>
@@ -2117,6 +2186,7 @@
                 <a:spcPts val="1200"/>
               </a:spcAft>
               <a:buChar char="•"/>
+              <a:defRPr/>
             </a:lvl7pPr>
             <a:lvl8pPr marL="2362200" indent="-228600">
               <a:lnSpc>
@@ -2129,6 +2199,7 @@
                 <a:spcPts val="1200"/>
               </a:spcAft>
               <a:buChar char="•"/>
+              <a:defRPr/>
             </a:lvl8pPr>
             <a:lvl9pPr marL="2667000" indent="-228600">
               <a:lnSpc>
@@ -2141,6 +2212,7 @@
                 <a:spcPts val="1200"/>
               </a:spcAft>
               <a:buChar char="•"/>
+              <a:defRPr/>
             </a:lvl9pPr>
           </a:lstStyle>
           <a:p xmlns:a="http://schemas.openxmlformats.org/drawingml/2006/main"/>
@@ -2219,6 +2291,7 @@
                 <a:spcPts val="0"/>
               </a:spcAft>
               <a:buNone/>
+              <a:defRPr/>
             </a:lvl1pPr>
             <a:lvl2pPr marL="0" indent="0">
               <a:lnSpc>
@@ -2231,6 +2304,7 @@
                 <a:spcPts val="0"/>
               </a:spcAft>
               <a:buNone/>
+              <a:defRPr/>
             </a:lvl2pPr>
             <a:lvl3pPr marL="0" indent="0">
               <a:lnSpc>
@@ -2243,6 +2317,7 @@
                 <a:spcPts val="0"/>
               </a:spcAft>
               <a:buNone/>
+              <a:defRPr/>
             </a:lvl3pPr>
             <a:lvl4pPr marL="0" indent="0">
               <a:lnSpc>
@@ -2255,6 +2330,7 @@
                 <a:spcPts val="0"/>
               </a:spcAft>
               <a:buNone/>
+              <a:defRPr/>
             </a:lvl4pPr>
             <a:lvl5pPr marL="0" indent="0">
               <a:lnSpc>
@@ -2267,6 +2343,7 @@
                 <a:spcPts val="0"/>
               </a:spcAft>
               <a:buNone/>
+              <a:defRPr/>
             </a:lvl5pPr>
             <a:lvl6pPr marL="0" indent="0">
               <a:lnSpc>
@@ -2279,6 +2356,7 @@
                 <a:spcPts val="0"/>
               </a:spcAft>
               <a:buNone/>
+              <a:defRPr/>
             </a:lvl6pPr>
             <a:lvl7pPr marL="0" indent="0">
               <a:lnSpc>
@@ -2291,6 +2369,7 @@
                 <a:spcPts val="0"/>
               </a:spcAft>
               <a:buNone/>
+              <a:defRPr/>
             </a:lvl7pPr>
             <a:lvl8pPr marL="0" indent="0">
               <a:lnSpc>
@@ -2303,6 +2382,7 @@
                 <a:spcPts val="0"/>
               </a:spcAft>
               <a:buNone/>
+              <a:defRPr/>
             </a:lvl8pPr>
             <a:lvl9pPr marL="0" indent="0">
               <a:lnSpc>
@@ -2315,6 +2395,7 @@
                 <a:spcPts val="0"/>
               </a:spcAft>
               <a:buNone/>
+              <a:defRPr/>
             </a:lvl9pPr>
           </a:lstStyle>
           <a:p xmlns:a="http://schemas.openxmlformats.org/drawingml/2006/main"/>
@@ -2376,6 +2457,7 @@
                 <a:spcPts val="1200"/>
               </a:spcAft>
               <a:buChar char="•"/>
+              <a:defRPr/>
             </a:lvl1pPr>
             <a:lvl2pPr marL="533400" indent="-228600">
               <a:lnSpc>
@@ -2388,6 +2470,7 @@
                 <a:spcPts val="1200"/>
               </a:spcAft>
               <a:buChar char="•"/>
+              <a:defRPr/>
             </a:lvl2pPr>
             <a:lvl3pPr marL="838200" indent="-228600">
               <a:lnSpc>
@@ -2400,6 +2483,7 @@
                 <a:spcPts val="1200"/>
               </a:spcAft>
               <a:buChar char="•"/>
+              <a:defRPr/>
             </a:lvl3pPr>
             <a:lvl4pPr marL="1143000" indent="-228600">
               <a:lnSpc>
@@ -2412,6 +2496,7 @@
                 <a:spcPts val="1200"/>
               </a:spcAft>
               <a:buChar char="•"/>
+              <a:defRPr/>
             </a:lvl4pPr>
             <a:lvl5pPr marL="1447800" indent="-228600">
               <a:lnSpc>
@@ -2424,6 +2509,7 @@
                 <a:spcPts val="1200"/>
               </a:spcAft>
               <a:buChar char="•"/>
+              <a:defRPr/>
             </a:lvl5pPr>
             <a:lvl6pPr marL="1752600" indent="-228600">
               <a:lnSpc>
@@ -2436,6 +2522,7 @@
                 <a:spcPts val="1200"/>
               </a:spcAft>
               <a:buChar char="•"/>
+              <a:defRPr/>
             </a:lvl6pPr>
             <a:lvl7pPr marL="2057400" indent="-228600">
               <a:lnSpc>
@@ -2448,6 +2535,7 @@
                 <a:spcPts val="1200"/>
               </a:spcAft>
               <a:buChar char="•"/>
+              <a:defRPr/>
             </a:lvl7pPr>
             <a:lvl8pPr marL="2362200" indent="-228600">
               <a:lnSpc>
@@ -2460,6 +2548,7 @@
                 <a:spcPts val="1200"/>
               </a:spcAft>
               <a:buChar char="•"/>
+              <a:defRPr/>
             </a:lvl8pPr>
             <a:lvl9pPr marL="2667000" indent="-228600">
               <a:lnSpc>
@@ -2472,6 +2561,7 @@
                 <a:spcPts val="1200"/>
               </a:spcAft>
               <a:buChar char="•"/>
+              <a:defRPr/>
             </a:lvl9pPr>
           </a:lstStyle>
           <a:p xmlns:a="http://schemas.openxmlformats.org/drawingml/2006/main"/>
@@ -2520,12 +2610,12 @@
   </p:cSld>
   <p:clrMap bg1="lt1" tx1="dk1" bg2="lt2" tx2="dk2" accent1="accent1" accent2="accent2" accent3="accent3" accent4="accent4" accent5="accent5" accent6="accent6" hlink="hlink" folHlink="folHlink"/>
   <p:sldLayoutIdLst>
-    <p:sldLayoutId xmlns:r="http://schemas.openxmlformats.org/officeDocument/2006/relationships" id="2147483649" r:id="Rb571e5060a9e4c05"/>
-    <p:sldLayoutId xmlns:r="http://schemas.openxmlformats.org/officeDocument/2006/relationships" id="2147483650" r:id="R21e8355abeff46f6"/>
-    <p:sldLayoutId xmlns:r="http://schemas.openxmlformats.org/officeDocument/2006/relationships" id="2147483651" r:id="R3d364bdfeb114724"/>
-    <p:sldLayoutId xmlns:r="http://schemas.openxmlformats.org/officeDocument/2006/relationships" id="2147483652" r:id="R1ea1e7a814b24fb5"/>
-    <p:sldLayoutId xmlns:r="http://schemas.openxmlformats.org/officeDocument/2006/relationships" id="2147483653" r:id="Rc351ccc575584632"/>
-    <p:sldLayoutId xmlns:r="http://schemas.openxmlformats.org/officeDocument/2006/relationships" id="2147483654" r:id="R4946636150374b85"/>
+    <p:sldLayoutId xmlns:r="http://schemas.openxmlformats.org/officeDocument/2006/relationships" id="2147483649" r:id="R7c5d28bd431249c2"/>
+    <p:sldLayoutId xmlns:r="http://schemas.openxmlformats.org/officeDocument/2006/relationships" id="2147483650" r:id="R610f3b87b13b49ee"/>
+    <p:sldLayoutId xmlns:r="http://schemas.openxmlformats.org/officeDocument/2006/relationships" id="2147483651" r:id="Rbee8a868e71640db"/>
+    <p:sldLayoutId xmlns:r="http://schemas.openxmlformats.org/officeDocument/2006/relationships" id="2147483652" r:id="R292a5fbb0e7d431b"/>
+    <p:sldLayoutId xmlns:r="http://schemas.openxmlformats.org/officeDocument/2006/relationships" id="2147483653" r:id="Rc042905d5e8e45c2"/>
+    <p:sldLayoutId xmlns:r="http://schemas.openxmlformats.org/officeDocument/2006/relationships" id="2147483654" r:id="R59fab2c5057449ec"/>
   </p:sldLayoutIdLst>
   <p:txStyles>
     <p:titleStyle>
@@ -3116,6 +3206,7 @@
           </a:lstStyle>
           <a:p xmlns:a="http://schemas.openxmlformats.org/drawingml/2006/main">
             <a:pPr>
+              <a:buNone/>
               <a:defRPr sz="5400" b="1">
                 <a:solidFill>
                   <a:srgbClr val="1C2D3F"/>
@@ -3139,6 +3230,7 @@
           </a:p>
           <a:p xmlns:a="http://schemas.openxmlformats.org/drawingml/2006/main">
             <a:pPr>
+              <a:buNone/>
               <a:defRPr sz="5400" b="1">
                 <a:solidFill>
                   <a:srgbClr val="1C2D3F"/>
@@ -3207,6 +3299,7 @@
           </a:lstStyle>
           <a:p xmlns:a="http://schemas.openxmlformats.org/drawingml/2006/main">
             <a:pPr>
+              <a:buNone/>
               <a:defRPr sz="2175" b="0">
                 <a:solidFill>
                   <a:srgbClr val="245680"/>
@@ -3275,6 +3368,7 @@
           </a:lstStyle>
           <a:p xmlns:a="http://schemas.openxmlformats.org/drawingml/2006/main">
             <a:pPr>
+              <a:buNone/>
               <a:defRPr sz="2025" b="0">
                 <a:solidFill>
                   <a:srgbClr val="1C2D3F"/>
@@ -3298,6 +3392,7 @@
           </a:p>
           <a:p xmlns:a="http://schemas.openxmlformats.org/drawingml/2006/main">
             <a:pPr>
+              <a:buNone/>
               <a:defRPr sz="2025" b="0">
                 <a:solidFill>
                   <a:srgbClr val="1C2D3F"/>
@@ -3366,6 +3461,7 @@
           </a:lstStyle>
           <a:p xmlns:a="http://schemas.openxmlformats.org/drawingml/2006/main">
             <a:pPr>
+              <a:buNone/>
               <a:defRPr sz="1575" b="0">
                 <a:solidFill>
                   <a:srgbClr val="526173"/>
@@ -3463,6 +3559,7 @@
           </a:lstStyle>
           <a:p xmlns:a="http://schemas.openxmlformats.org/drawingml/2006/main">
             <a:pPr>
+              <a:buNone/>
               <a:defRPr sz="3225" b="1">
                 <a:solidFill>
                   <a:srgbClr val="1C2D3F"/>
@@ -3531,6 +3628,7 @@
           </a:lstStyle>
           <a:p xmlns:a="http://schemas.openxmlformats.org/drawingml/2006/main">
             <a:pPr>
+              <a:buNone/>
               <a:defRPr sz="2100" b="1">
                 <a:solidFill>
                   <a:srgbClr val="245680"/>
@@ -3599,6 +3697,7 @@
           </a:lstStyle>
           <a:p xmlns:a="http://schemas.openxmlformats.org/drawingml/2006/main">
             <a:pPr>
+              <a:buNone/>
               <a:defRPr sz="1875" b="0">
                 <a:solidFill>
                   <a:srgbClr val="1C2D3F"/>
@@ -3622,6 +3721,7 @@
           </a:p>
           <a:p xmlns:a="http://schemas.openxmlformats.org/drawingml/2006/main">
             <a:pPr>
+              <a:buNone/>
               <a:defRPr sz="1875" b="0">
                 <a:solidFill>
                   <a:srgbClr val="1C2D3F"/>
@@ -3690,6 +3790,7 @@
           </a:lstStyle>
           <a:p xmlns:a="http://schemas.openxmlformats.org/drawingml/2006/main">
             <a:pPr>
+              <a:buNone/>
               <a:defRPr sz="2100" b="1">
                 <a:solidFill>
                   <a:srgbClr val="245680"/>
@@ -3758,6 +3859,7 @@
           </a:lstStyle>
           <a:p xmlns:a="http://schemas.openxmlformats.org/drawingml/2006/main">
             <a:pPr>
+              <a:buNone/>
               <a:defRPr sz="1875" b="0">
                 <a:solidFill>
                   <a:srgbClr val="1C2D3F"/>
@@ -3781,6 +3883,7 @@
           </a:p>
           <a:p xmlns:a="http://schemas.openxmlformats.org/drawingml/2006/main">
             <a:pPr>
+              <a:buNone/>
               <a:defRPr sz="1875" b="0">
                 <a:solidFill>
                   <a:srgbClr val="1C2D3F"/>
@@ -3849,6 +3952,7 @@
           </a:lstStyle>
           <a:p xmlns:a="http://schemas.openxmlformats.org/drawingml/2006/main">
             <a:pPr>
+              <a:buNone/>
               <a:defRPr sz="1950" b="1">
                 <a:solidFill>
                   <a:srgbClr val="1C2D3F"/>
@@ -3872,6 +3976,7 @@
           </a:p>
           <a:p xmlns:a="http://schemas.openxmlformats.org/drawingml/2006/main">
             <a:pPr>
+              <a:buNone/>
               <a:defRPr sz="1950" b="1">
                 <a:solidFill>
                   <a:srgbClr val="1C2D3F"/>
@@ -3900,7 +4005,7 @@
           <p:cNvPr id="7" name="">
             <a:extLst xmlns:a="http://schemas.openxmlformats.org/drawingml/2006/main">
               <a:ext uri="{FF2B5EF4-FFF2-40B4-BE49-F238E27FC236}">
-                <a16:creationId xmlns:a16="http://schemas.microsoft.com/office/drawing/2014/main" id="{9138BE18-C4BB-4D16-BA4E-CBB54EBADA25}"/>
+                <a16:creationId xmlns:a16="http://schemas.microsoft.com/office/drawing/2014/main" id="{8BF1E429-EE87-47D5-986D-2DC56DCF102D}"/>
               </a:ext>
             </a:extLst>
           </p:cNvPr>
@@ -3910,7 +4015,7 @@
           <p:nvPr/>
         </p:nvPicPr>
         <p:blipFill>
-          <a:blip xmlns:r="http://schemas.openxmlformats.org/officeDocument/2006/relationships" xmlns:a="http://schemas.openxmlformats.org/drawingml/2006/main" r:embed="Re56c3940d2de40d8"/>
+          <a:blip xmlns:r="http://schemas.openxmlformats.org/officeDocument/2006/relationships" xmlns:a="http://schemas.openxmlformats.org/drawingml/2006/main" r:embed="Rdc32b37f93f54636"/>
           <a:stretch xmlns:a="http://schemas.openxmlformats.org/drawingml/2006/main"/>
         </p:blipFill>
         <p:spPr>
@@ -3997,6 +4102,7 @@
           </a:lstStyle>
           <a:p xmlns:a="http://schemas.openxmlformats.org/drawingml/2006/main">
             <a:pPr>
+              <a:buNone/>
               <a:defRPr sz="3225" b="1">
                 <a:solidFill>
                   <a:srgbClr val="1C2D3F"/>
@@ -4065,6 +4171,7 @@
           </a:lstStyle>
           <a:p xmlns:a="http://schemas.openxmlformats.org/drawingml/2006/main">
             <a:pPr>
+              <a:buNone/>
               <a:defRPr sz="1875" b="0">
                 <a:solidFill>
                   <a:srgbClr val="526173"/>
@@ -4165,6 +4272,7 @@
           </a:lstStyle>
           <a:p xmlns:a="http://schemas.openxmlformats.org/drawingml/2006/main">
             <a:pPr>
+              <a:buNone/>
               <a:defRPr sz="2100" b="1">
                 <a:solidFill>
                   <a:srgbClr val="245680"/>
@@ -4233,6 +4341,7 @@
           </a:lstStyle>
           <a:p xmlns:a="http://schemas.openxmlformats.org/drawingml/2006/main">
             <a:pPr>
+              <a:buNone/>
               <a:defRPr sz="1650" b="0">
                 <a:solidFill>
                   <a:srgbClr val="526173"/>
@@ -4256,6 +4365,7 @@
           </a:p>
           <a:p xmlns:a="http://schemas.openxmlformats.org/drawingml/2006/main">
             <a:pPr>
+              <a:buNone/>
               <a:defRPr sz="1650" b="0">
                 <a:solidFill>
                   <a:srgbClr val="526173"/>
@@ -4356,6 +4466,7 @@
           </a:lstStyle>
           <a:p xmlns:a="http://schemas.openxmlformats.org/drawingml/2006/main">
             <a:pPr>
+              <a:buNone/>
               <a:defRPr sz="2100" b="1">
                 <a:solidFill>
                   <a:srgbClr val="245680"/>
@@ -4424,6 +4535,7 @@
           </a:lstStyle>
           <a:p xmlns:a="http://schemas.openxmlformats.org/drawingml/2006/main">
             <a:pPr>
+              <a:buNone/>
               <a:defRPr sz="1650" b="0">
                 <a:solidFill>
                   <a:srgbClr val="526173"/>
@@ -4447,6 +4559,7 @@
           </a:p>
           <a:p xmlns:a="http://schemas.openxmlformats.org/drawingml/2006/main">
             <a:pPr>
+              <a:buNone/>
               <a:defRPr sz="1650" b="0">
                 <a:solidFill>
                   <a:srgbClr val="526173"/>
@@ -4547,6 +4660,7 @@
           </a:lstStyle>
           <a:p xmlns:a="http://schemas.openxmlformats.org/drawingml/2006/main">
             <a:pPr>
+              <a:buNone/>
               <a:defRPr sz="2100" b="1">
                 <a:solidFill>
                   <a:srgbClr val="245680"/>
@@ -4615,6 +4729,7 @@
           </a:lstStyle>
           <a:p xmlns:a="http://schemas.openxmlformats.org/drawingml/2006/main">
             <a:pPr>
+              <a:buNone/>
               <a:defRPr sz="1650" b="0">
                 <a:solidFill>
                   <a:srgbClr val="526173"/>
@@ -4638,6 +4753,7 @@
           </a:p>
           <a:p xmlns:a="http://schemas.openxmlformats.org/drawingml/2006/main">
             <a:pPr>
+              <a:buNone/>
               <a:defRPr sz="1650" b="0">
                 <a:solidFill>
                   <a:srgbClr val="526173"/>
@@ -4706,6 +4822,7 @@
           </a:lstStyle>
           <a:p xmlns:a="http://schemas.openxmlformats.org/drawingml/2006/main">
             <a:pPr>
+              <a:buNone/>
               <a:defRPr sz="3150" b="0">
                 <a:solidFill>
                   <a:srgbClr val="245680"/>
@@ -4774,6 +4891,7 @@
           </a:lstStyle>
           <a:p xmlns:a="http://schemas.openxmlformats.org/drawingml/2006/main">
             <a:pPr>
+              <a:buNone/>
               <a:defRPr sz="3150" b="0">
                 <a:solidFill>
                   <a:srgbClr val="245680"/>
@@ -4842,6 +4960,7 @@
           </a:lstStyle>
           <a:p xmlns:a="http://schemas.openxmlformats.org/drawingml/2006/main">
             <a:pPr>
+              <a:buNone/>
               <a:defRPr sz="2100" b="1">
                 <a:solidFill>
                   <a:srgbClr val="245680"/>
@@ -4910,6 +5029,7 @@
           </a:lstStyle>
           <a:p xmlns:a="http://schemas.openxmlformats.org/drawingml/2006/main">
             <a:pPr>
+              <a:buNone/>
               <a:defRPr sz="1950" b="0">
                 <a:solidFill>
                   <a:srgbClr val="1C2D3F"/>
@@ -4933,6 +5053,7 @@
           </a:p>
           <a:p xmlns:a="http://schemas.openxmlformats.org/drawingml/2006/main">
             <a:pPr>
+              <a:buNone/>
               <a:defRPr sz="1950" b="0">
                 <a:solidFill>
                   <a:srgbClr val="1C2D3F"/>
@@ -5001,6 +5122,7 @@
           </a:lstStyle>
           <a:p xmlns:a="http://schemas.openxmlformats.org/drawingml/2006/main">
             <a:pPr>
+              <a:buNone/>
               <a:defRPr sz="1950" b="0">
                 <a:solidFill>
                   <a:srgbClr val="1C2D3F"/>
@@ -5024,6 +5146,7 @@
           </a:p>
           <a:p xmlns:a="http://schemas.openxmlformats.org/drawingml/2006/main">
             <a:pPr>
+              <a:buNone/>
               <a:defRPr sz="1950" b="0">
                 <a:solidFill>
                   <a:srgbClr val="1C2D3F"/>
@@ -5092,6 +5215,7 @@
           </a:lstStyle>
           <a:p xmlns:a="http://schemas.openxmlformats.org/drawingml/2006/main">
             <a:pPr>
+              <a:buNone/>
               <a:defRPr sz="1950" b="0">
                 <a:solidFill>
                   <a:srgbClr val="1C2D3F"/>
@@ -5115,6 +5239,7 @@
           </a:p>
           <a:p xmlns:a="http://schemas.openxmlformats.org/drawingml/2006/main">
             <a:pPr>
+              <a:buNone/>
               <a:defRPr sz="1950" b="0">
                 <a:solidFill>
                   <a:srgbClr val="1C2D3F"/>
@@ -5183,6 +5308,7 @@
           </a:lstStyle>
           <a:p xmlns:a="http://schemas.openxmlformats.org/drawingml/2006/main">
             <a:pPr>
+              <a:buNone/>
               <a:defRPr sz="1950" b="0">
                 <a:solidFill>
                   <a:srgbClr val="1C2D3F"/>
@@ -5206,6 +5332,7 @@
           </a:p>
           <a:p xmlns:a="http://schemas.openxmlformats.org/drawingml/2006/main">
             <a:pPr>
+              <a:buNone/>
               <a:defRPr sz="1950" b="0">
                 <a:solidFill>
                   <a:srgbClr val="1C2D3F"/>
@@ -5303,6 +5430,7 @@
           </a:lstStyle>
           <a:p xmlns:a="http://schemas.openxmlformats.org/drawingml/2006/main">
             <a:pPr>
+              <a:buNone/>
               <a:defRPr sz="3225" b="1">
                 <a:solidFill>
                   <a:srgbClr val="1C2D3F"/>
@@ -5371,6 +5499,7 @@
           </a:lstStyle>
           <a:p xmlns:a="http://schemas.openxmlformats.org/drawingml/2006/main">
             <a:pPr>
+              <a:buNone/>
               <a:defRPr sz="1875" b="1">
                 <a:solidFill>
                   <a:srgbClr val="245680"/>
@@ -5439,6 +5568,7 @@
           </a:lstStyle>
           <a:p xmlns:a="http://schemas.openxmlformats.org/drawingml/2006/main">
             <a:pPr>
+              <a:buNone/>
               <a:defRPr sz="1875" b="0">
                 <a:solidFill>
                   <a:srgbClr val="1C2D3F"/>
@@ -5507,6 +5637,7 @@
           </a:lstStyle>
           <a:p xmlns:a="http://schemas.openxmlformats.org/drawingml/2006/main">
             <a:pPr>
+              <a:buNone/>
               <a:defRPr sz="1875" b="1">
                 <a:solidFill>
                   <a:srgbClr val="245680"/>
@@ -5575,6 +5706,7 @@
           </a:lstStyle>
           <a:p xmlns:a="http://schemas.openxmlformats.org/drawingml/2006/main">
             <a:pPr>
+              <a:buNone/>
               <a:defRPr sz="1875" b="0">
                 <a:solidFill>
                   <a:srgbClr val="1C2D3F"/>
@@ -5643,6 +5775,7 @@
           </a:lstStyle>
           <a:p xmlns:a="http://schemas.openxmlformats.org/drawingml/2006/main">
             <a:pPr>
+              <a:buNone/>
               <a:defRPr sz="1875" b="1">
                 <a:solidFill>
                   <a:srgbClr val="245680"/>
@@ -5711,6 +5844,7 @@
           </a:lstStyle>
           <a:p xmlns:a="http://schemas.openxmlformats.org/drawingml/2006/main">
             <a:pPr>
+              <a:buNone/>
               <a:defRPr sz="1875" b="0">
                 <a:solidFill>
                   <a:srgbClr val="1C2D3F"/>
@@ -5779,6 +5913,7 @@
           </a:lstStyle>
           <a:p xmlns:a="http://schemas.openxmlformats.org/drawingml/2006/main">
             <a:pPr>
+              <a:buNone/>
               <a:defRPr sz="1875" b="1">
                 <a:solidFill>
                   <a:srgbClr val="245680"/>
@@ -5847,6 +5982,7 @@
           </a:lstStyle>
           <a:p xmlns:a="http://schemas.openxmlformats.org/drawingml/2006/main">
             <a:pPr>
+              <a:buNone/>
               <a:defRPr sz="1875" b="0">
                 <a:solidFill>
                   <a:srgbClr val="1C2D3F"/>
@@ -5915,6 +6051,7 @@
           </a:lstStyle>
           <a:p xmlns:a="http://schemas.openxmlformats.org/drawingml/2006/main">
             <a:pPr>
+              <a:buNone/>
               <a:defRPr sz="1875" b="1">
                 <a:solidFill>
                   <a:srgbClr val="245680"/>
@@ -5983,6 +6120,7 @@
           </a:lstStyle>
           <a:p xmlns:a="http://schemas.openxmlformats.org/drawingml/2006/main">
             <a:pPr>
+              <a:buNone/>
               <a:defRPr sz="1875" b="0">
                 <a:solidFill>
                   <a:srgbClr val="1C2D3F"/>
@@ -6051,6 +6189,7 @@
           </a:lstStyle>
           <a:p xmlns:a="http://schemas.openxmlformats.org/drawingml/2006/main">
             <a:pPr>
+              <a:buNone/>
               <a:defRPr sz="1875" b="1">
                 <a:solidFill>
                   <a:srgbClr val="245680"/>
@@ -6119,6 +6258,7 @@
           </a:lstStyle>
           <a:p xmlns:a="http://schemas.openxmlformats.org/drawingml/2006/main">
             <a:pPr>
+              <a:buNone/>
               <a:defRPr sz="1875" b="0">
                 <a:solidFill>
                   <a:srgbClr val="1C2D3F"/>
@@ -6187,6 +6327,7 @@
           </a:lstStyle>
           <a:p xmlns:a="http://schemas.openxmlformats.org/drawingml/2006/main">
             <a:pPr>
+              <a:buNone/>
               <a:defRPr sz="1875" b="1">
                 <a:solidFill>
                   <a:srgbClr val="245680"/>
@@ -6255,6 +6396,7 @@
           </a:lstStyle>
           <a:p xmlns:a="http://schemas.openxmlformats.org/drawingml/2006/main">
             <a:pPr>
+              <a:buNone/>
               <a:defRPr sz="1875" b="0">
                 <a:solidFill>
                   <a:srgbClr val="1C2D3F"/>
@@ -6323,6 +6465,7 @@
           </a:lstStyle>
           <a:p xmlns:a="http://schemas.openxmlformats.org/drawingml/2006/main">
             <a:pPr>
+              <a:buNone/>
               <a:defRPr sz="2325" b="1">
                 <a:solidFill>
                   <a:srgbClr val="245680"/>
@@ -6391,6 +6534,7 @@
           </a:lstStyle>
           <a:p xmlns:a="http://schemas.openxmlformats.org/drawingml/2006/main">
             <a:pPr>
+              <a:buNone/>
               <a:defRPr sz="1875" b="0">
                 <a:solidFill>
                   <a:srgbClr val="1C2D3F"/>
@@ -6414,6 +6558,7 @@
           </a:p>
           <a:p xmlns:a="http://schemas.openxmlformats.org/drawingml/2006/main">
             <a:pPr>
+              <a:buNone/>
               <a:defRPr sz="1875" b="0">
                 <a:solidFill>
                   <a:srgbClr val="1C2D3F"/>
@@ -6482,6 +6627,7 @@
           </a:lstStyle>
           <a:p xmlns:a="http://schemas.openxmlformats.org/drawingml/2006/main">
             <a:pPr>
+              <a:buNone/>
               <a:defRPr sz="1875" b="0">
                 <a:solidFill>
                   <a:srgbClr val="1C2D3F"/>
@@ -6505,6 +6651,7 @@
           </a:p>
           <a:p xmlns:a="http://schemas.openxmlformats.org/drawingml/2006/main">
             <a:pPr>
+              <a:buNone/>
               <a:defRPr sz="1875" b="0">
                 <a:solidFill>
                   <a:srgbClr val="1C2D3F"/>
@@ -6573,6 +6720,7 @@
           </a:lstStyle>
           <a:p xmlns:a="http://schemas.openxmlformats.org/drawingml/2006/main">
             <a:pPr>
+              <a:buNone/>
               <a:defRPr sz="1875" b="1">
                 <a:solidFill>
                   <a:srgbClr val="1C2D3F"/>
@@ -6596,6 +6744,7 @@
           </a:p>
           <a:p xmlns:a="http://schemas.openxmlformats.org/drawingml/2006/main">
             <a:pPr>
+              <a:buNone/>
               <a:defRPr sz="1875" b="1">
                 <a:solidFill>
                   <a:srgbClr val="1C2D3F"/>
@@ -6693,6 +6842,7 @@
           </a:lstStyle>
           <a:p xmlns:a="http://schemas.openxmlformats.org/drawingml/2006/main">
             <a:pPr>
+              <a:buNone/>
               <a:defRPr sz="3225" b="1">
                 <a:solidFill>
                   <a:srgbClr val="1C2D3F"/>
@@ -6761,6 +6911,7 @@
           </a:lstStyle>
           <a:p xmlns:a="http://schemas.openxmlformats.org/drawingml/2006/main">
             <a:pPr>
+              <a:buNone/>
               <a:defRPr sz="2100" b="1">
                 <a:solidFill>
                   <a:srgbClr val="245680"/>
@@ -6829,6 +6980,7 @@
           </a:lstStyle>
           <a:p xmlns:a="http://schemas.openxmlformats.org/drawingml/2006/main">
             <a:pPr>
+              <a:buNone/>
               <a:defRPr sz="2100" b="1">
                 <a:solidFill>
                   <a:srgbClr val="245680"/>
@@ -6857,7 +7009,7 @@
           <p:cNvPr id="4" name="">
             <a:extLst xmlns:a="http://schemas.openxmlformats.org/drawingml/2006/main">
               <a:ext uri="{FF2B5EF4-FFF2-40B4-BE49-F238E27FC236}">
-                <a16:creationId xmlns:a16="http://schemas.microsoft.com/office/drawing/2014/main" id="{DBA801AF-3F49-4921-9F32-CF49538C8B2E}"/>
+                <a16:creationId xmlns:a16="http://schemas.microsoft.com/office/drawing/2014/main" id="{A5FDC3F1-A466-4908-ACAB-CE85D285AB5B}"/>
               </a:ext>
             </a:extLst>
           </p:cNvPr>
@@ -6867,7 +7019,7 @@
           <p:nvPr/>
         </p:nvPicPr>
         <p:blipFill>
-          <a:blip xmlns:r="http://schemas.openxmlformats.org/officeDocument/2006/relationships" xmlns:a="http://schemas.openxmlformats.org/drawingml/2006/main" r:embed="Rced8db87568f4b6e"/>
+          <a:blip xmlns:r="http://schemas.openxmlformats.org/officeDocument/2006/relationships" xmlns:a="http://schemas.openxmlformats.org/drawingml/2006/main" r:embed="Re4bbbc3731434bcc"/>
           <a:stretch xmlns:a="http://schemas.openxmlformats.org/drawingml/2006/main"/>
         </p:blipFill>
         <p:spPr>
@@ -6885,7 +7037,7 @@
           <p:cNvPr id="5" name="">
             <a:extLst xmlns:a="http://schemas.openxmlformats.org/drawingml/2006/main">
               <a:ext uri="{FF2B5EF4-FFF2-40B4-BE49-F238E27FC236}">
-                <a16:creationId xmlns:a16="http://schemas.microsoft.com/office/drawing/2014/main" id="{8278B1C8-4A6D-40D9-8D96-D6F43FDEE22F}"/>
+                <a16:creationId xmlns:a16="http://schemas.microsoft.com/office/drawing/2014/main" id="{FED3A295-9335-476C-9848-1365255D76C0}"/>
               </a:ext>
             </a:extLst>
           </p:cNvPr>
@@ -6895,7 +7047,7 @@
           <p:nvPr/>
         </p:nvPicPr>
         <p:blipFill>
-          <a:blip xmlns:r="http://schemas.openxmlformats.org/officeDocument/2006/relationships" xmlns:a="http://schemas.openxmlformats.org/drawingml/2006/main" r:embed="R29b66062f77e4007"/>
+          <a:blip xmlns:r="http://schemas.openxmlformats.org/officeDocument/2006/relationships" xmlns:a="http://schemas.openxmlformats.org/drawingml/2006/main" r:embed="R308afafa07624ab8"/>
           <a:srcRect xmlns:a="http://schemas.openxmlformats.org/drawingml/2006/main" l="0" t="0" r="0" b="59200"/>
           <a:stretch xmlns:a="http://schemas.openxmlformats.org/drawingml/2006/main"/>
         </p:blipFill>
@@ -6954,6 +7106,7 @@
           </a:lstStyle>
           <a:p xmlns:a="http://schemas.openxmlformats.org/drawingml/2006/main">
             <a:pPr>
+              <a:buNone/>
               <a:defRPr sz="1500" b="0">
                 <a:solidFill>
                   <a:srgbClr val="526173"/>
@@ -7051,6 +7204,7 @@
           </a:lstStyle>
           <a:p xmlns:a="http://schemas.openxmlformats.org/drawingml/2006/main">
             <a:pPr>
+              <a:buNone/>
               <a:defRPr sz="3225" b="1">
                 <a:solidFill>
                   <a:srgbClr val="1C2D3F"/>
@@ -7119,6 +7273,7 @@
           </a:lstStyle>
           <a:p xmlns:a="http://schemas.openxmlformats.org/drawingml/2006/main">
             <a:pPr>
+              <a:buNone/>
               <a:defRPr sz="2175" b="1">
                 <a:solidFill>
                   <a:srgbClr val="245680"/>
@@ -7187,6 +7342,7 @@
           </a:lstStyle>
           <a:p xmlns:a="http://schemas.openxmlformats.org/drawingml/2006/main">
             <a:pPr>
+              <a:buNone/>
               <a:defRPr sz="2025" b="0">
                 <a:solidFill>
                   <a:srgbClr val="1C2D3F"/>
@@ -7210,6 +7366,7 @@
           </a:p>
           <a:p xmlns:a="http://schemas.openxmlformats.org/drawingml/2006/main">
             <a:pPr>
+              <a:buNone/>
               <a:defRPr sz="2025" b="0">
                 <a:solidFill>
                   <a:srgbClr val="1C2D3F"/>
@@ -7233,6 +7390,7 @@
           </a:p>
           <a:p xmlns:a="http://schemas.openxmlformats.org/drawingml/2006/main">
             <a:pPr>
+              <a:buNone/>
               <a:defRPr sz="2025" b="0">
                 <a:solidFill>
                   <a:srgbClr val="1C2D3F"/>
@@ -7301,6 +7459,7 @@
           </a:lstStyle>
           <a:p xmlns:a="http://schemas.openxmlformats.org/drawingml/2006/main">
             <a:pPr>
+              <a:buNone/>
               <a:defRPr sz="2175" b="1">
                 <a:solidFill>
                   <a:srgbClr val="245680"/>
@@ -7369,6 +7528,7 @@
           </a:lstStyle>
           <a:p xmlns:a="http://schemas.openxmlformats.org/drawingml/2006/main">
             <a:pPr>
+              <a:buNone/>
               <a:defRPr sz="2025" b="0">
                 <a:solidFill>
                   <a:srgbClr val="1C2D3F"/>
@@ -7392,6 +7552,7 @@
           </a:p>
           <a:p xmlns:a="http://schemas.openxmlformats.org/drawingml/2006/main">
             <a:pPr>
+              <a:buNone/>
               <a:defRPr sz="2025" b="0">
                 <a:solidFill>
                   <a:srgbClr val="1C2D3F"/>
@@ -7415,6 +7576,7 @@
           </a:p>
           <a:p xmlns:a="http://schemas.openxmlformats.org/drawingml/2006/main">
             <a:pPr>
+              <a:buNone/>
               <a:defRPr sz="2025" b="0">
                 <a:solidFill>
                   <a:srgbClr val="1C2D3F"/>
@@ -7483,6 +7645,7 @@
           </a:lstStyle>
           <a:p xmlns:a="http://schemas.openxmlformats.org/drawingml/2006/main">
             <a:pPr>
+              <a:buNone/>
               <a:defRPr sz="2175" b="1">
                 <a:solidFill>
                   <a:srgbClr val="245680"/>
@@ -7551,6 +7714,7 @@
           </a:lstStyle>
           <a:p xmlns:a="http://schemas.openxmlformats.org/drawingml/2006/main">
             <a:pPr>
+              <a:buNone/>
               <a:defRPr sz="2025" b="0">
                 <a:solidFill>
                   <a:srgbClr val="1C2D3F"/>
@@ -7574,6 +7738,7 @@
           </a:p>
           <a:p xmlns:a="http://schemas.openxmlformats.org/drawingml/2006/main">
             <a:pPr>
+              <a:buNone/>
               <a:defRPr sz="2025" b="0">
                 <a:solidFill>
                   <a:srgbClr val="1C2D3F"/>
@@ -7642,6 +7807,7 @@
           </a:lstStyle>
           <a:p xmlns:a="http://schemas.openxmlformats.org/drawingml/2006/main">
             <a:pPr>
+              <a:buNone/>
               <a:defRPr sz="2175" b="1">
                 <a:solidFill>
                   <a:srgbClr val="245680"/>
@@ -7710,6 +7876,7 @@
           </a:lstStyle>
           <a:p xmlns:a="http://schemas.openxmlformats.org/drawingml/2006/main">
             <a:pPr>
+              <a:buNone/>
               <a:defRPr sz="2025" b="0">
                 <a:solidFill>
                   <a:srgbClr val="1C2D3F"/>
@@ -7733,6 +7900,7 @@
           </a:p>
           <a:p xmlns:a="http://schemas.openxmlformats.org/drawingml/2006/main">
             <a:pPr>
+              <a:buNone/>
               <a:defRPr sz="2025" b="0">
                 <a:solidFill>
                   <a:srgbClr val="1C2D3F"/>
@@ -7752,74 +7920,6 @@
                 <a:cs typeface="Arial"/>
               </a:rPr>
               <a:t>Acompanhamento do estudo</a:t>
-            </a:r>
-          </a:p>
-        </p:txBody>
-      </p:sp>
-      <p:sp>
-        <p:nvSpPr>
-          <p:cNvPr id="10" name="">
-            <a:extLst xmlns:a="http://schemas.openxmlformats.org/drawingml/2006/main">
-              <a:ext uri="{FF2B5EF4-FFF2-40B4-BE49-F238E27FC236}">
-                <a16:creationId xmlns:a16="http://schemas.microsoft.com/office/drawing/2014/main" id="{66AACB9A-72C6-4B19-BEE5-06E15FD6D550}"/>
-              </a:ext>
-            </a:extLst>
-          </p:cNvPr>
-          <p:cNvSpPr>
-            <a:spLocks xmlns:a="http://schemas.openxmlformats.org/drawingml/2006/main" noGrp="1"/>
-          </p:cNvSpPr>
-          <p:nvPr/>
-        </p:nvSpPr>
-        <p:spPr>
-          <a:xfrm xmlns:a="http://schemas.openxmlformats.org/drawingml/2006/main">
-            <a:off x="609600" y="6229350"/>
-            <a:ext cx="10972800" cy="381000"/>
-          </a:xfrm>
-          <a:prstGeom xmlns:a="http://schemas.openxmlformats.org/drawingml/2006/main" prst="rect">
-            <a:avLst/>
-          </a:prstGeom>
-          <a:noFill xmlns:a="http://schemas.openxmlformats.org/drawingml/2006/main"/>
-          <a:ln xmlns:a="http://schemas.openxmlformats.org/drawingml/2006/main" w="0">
-            <a:noFill/>
-          </a:ln>
-        </p:spPr>
-        <p:txBody>
-          <a:bodyPr xmlns:a="http://schemas.openxmlformats.org/drawingml/2006/main">
-            <a:noAutofit/>
-          </a:bodyPr>
-          <a:lstStyle xmlns:a="http://schemas.openxmlformats.org/drawingml/2006/main">
-            <a:defPPr>
-              <a:defRPr sz="1575" b="0">
-                <a:solidFill>
-                  <a:srgbClr val="526173"/>
-                </a:solidFill>
-                <a:latin typeface="Arial"/>
-                <a:ea typeface="Arial"/>
-                <a:cs typeface="Arial"/>
-              </a:defRPr>
-            </a:defPPr>
-          </a:lstStyle>
-          <a:p xmlns:a="http://schemas.openxmlformats.org/drawingml/2006/main">
-            <a:pPr>
-              <a:defRPr sz="1575" b="0">
-                <a:solidFill>
-                  <a:srgbClr val="526173"/>
-                </a:solidFill>
-                <a:latin typeface="Arial"/>
-                <a:ea typeface="Arial"/>
-                <a:cs typeface="Arial"/>
-              </a:defRPr>
-            </a:pPr>
-            <a:r>
-              <a:rPr sz="1575" b="0">
-                <a:solidFill>
-                  <a:srgbClr val="526173"/>
-                </a:solidFill>
-                <a:latin typeface="Arial"/>
-                <a:ea typeface="Arial"/>
-                <a:cs typeface="Arial"/>
-              </a:rPr>
-              <a:t>O estudante deve conferir o conteúdo gerado com seu material e professor.</a:t>
             </a:r>
           </a:p>
         </p:txBody>

</xml_diff>